<commit_message>
Fix pipeline to generate complete lesson plans with zero placeholders
Stage 1 parser fixes:
- Recover schedule blocks misclassified as evidence_statements
- Merge pacing sub-blocks into parent activity blocks
- Merge orphan Delivery:/Format: blocks into parents
- Fix chronological sorting (AM before PM)
- Clean SWBATs: remove noise lines like "Session N Contribution"

Stage 3 generator rewrite:
- Generate real Teacher Does content from delivery instructions
- Derive Students Do actions from activity format and context
- Generate specific CFU questions tied to SWBATs per block
- Generate activity-specific Teacher Tips (not placeholders)
- Generate concrete differentiation strategies per level
- Generate assessable exit ticket questions per SWBAT
- Clean Bloom's/Format/Delivery metadata from output text
- Zero _[...]_ placeholders in any generated lesson plan

https://claude.ai/code/session_015sE5Rx9MmzTtcPWqdXyaT6
</commit_message>
<xml_diff>
--- a/curriculum-planner/output/slides/session_01_slides.pptx
+++ b/curriculum-planner/output/slides/session_01_slides.pptx
@@ -24,7 +24,6 @@
     <p:sldId id="272" r:id="rId23"/>
     <p:sldId id="273" r:id="rId24"/>
     <p:sldId id="274" r:id="rId25"/>
-    <p:sldId id="275" r:id="rId26"/>
   </p:sldIdLst>
   <p:sldSz cx="12191695" cy="6858000" type="screen4x3"/>
   <p:notesSz cx="6858000" cy="9144000"/>
@@ -3179,7 +3178,7 @@
           <a:lstStyle/>
           <a:p>
             <a:r>
-              <a:t>Activity: Pivot Table Mastery  |✆</a:t>
+              <a:t>Activity: Data Cleaning — The Ugly Truth</a:t>
             </a:r>
           </a:p>
         </p:txBody>
@@ -3200,12 +3199,42 @@
           <a:lstStyle/>
           <a:p>
             <a:r>
-              <a:t>Duration: 45 min</a:t>
+              <a:t>Duration: 30 min</a:t>
             </a:r>
           </a:p>
           <a:p>
             <a:r>
               <a:t>Format: Whole Class</a:t>
+            </a:r>
+          </a:p>
+          <a:p>
+            <a:pPr lvl="1"/>
+            <a:r>
+              <a:t>Format: Hands-on, guided</a:t>
+            </a:r>
+          </a:p>
+          <a:p>
+            <a:pPr lvl="1"/>
+            <a:r>
+              <a:t>Bloom’s: Apply Delivery: Duplicates, blanks, inconsistent…</a:t>
+            </a:r>
+          </a:p>
+          <a:p>
+            <a:pPr lvl="1"/>
+            <a:r>
+              <a:t>Students clean a deliberately messy version…</a:t>
+            </a:r>
+          </a:p>
+          <a:p>
+            <a:pPr lvl="1"/>
+            <a:r>
+              <a:t>Teach each cleaning technique by encountering…</a:t>
+            </a:r>
+          </a:p>
+          <a:p>
+            <a:pPr lvl="1"/>
+            <a:r>
+              <a:t>” This is the work nobody…</a:t>
             </a:r>
           </a:p>
         </p:txBody>
@@ -3244,7 +3273,7 @@
           <a:lstStyle/>
           <a:p>
             <a:r>
-              <a:t>Activity: Break</a:t>
+              <a:t>Activity: Pivot Table Mastery  |✆</a:t>
             </a:r>
           </a:p>
         </p:txBody>
@@ -3265,7 +3294,7 @@
           <a:lstStyle/>
           <a:p>
             <a:r>
-              <a:t>Duration: 15 min</a:t>
+              <a:t>Duration: 45 min</a:t>
             </a:r>
           </a:p>
           <a:p>
@@ -3309,7 +3338,7 @@
           <a:lstStyle/>
           <a:p>
             <a:r>
-              <a:t>Activity: Visualization Fundamentals</a:t>
+              <a:t>Activity: Break</a:t>
             </a:r>
           </a:p>
         </p:txBody>
@@ -3330,42 +3359,12 @@
           <a:lstStyle/>
           <a:p>
             <a:r>
-              <a:t>Duration: 40 min</a:t>
+              <a:t>Duration: 15 min</a:t>
             </a:r>
           </a:p>
           <a:p>
             <a:r>
               <a:t>Format: Whole Class</a:t>
-            </a:r>
-          </a:p>
-          <a:p>
-            <a:pPr lvl="1"/>
-            <a:r>
-              <a:t>Format: Hands-on + peer review</a:t>
-            </a:r>
-          </a:p>
-          <a:p>
-            <a:pPr lvl="1"/>
-            <a:r>
-              <a:t>Bloom’s: Apply + Evaluate Delivery: When…</a:t>
-            </a:r>
-          </a:p>
-          <a:p>
-            <a:pPr lvl="1"/>
-            <a:r>
-              <a:t>line vs</a:t>
-            </a:r>
-          </a:p>
-          <a:p>
-            <a:pPr lvl="1"/>
-            <a:r>
-              <a:t>scatter (rule: almost never use a…</a:t>
-            </a:r>
-          </a:p>
-          <a:p>
-            <a:pPr lvl="1"/>
-            <a:r>
-              <a:t>Design principles: label axes, no 3D,…</a:t>
             </a:r>
           </a:p>
         </p:txBody>
@@ -3404,7 +3403,7 @@
           <a:lstStyle/>
           <a:p>
             <a:r>
-              <a:t>Activity: Pacing: Teach principles + chart type selection =. Students create 3 charts =. Peer comparison (swap screens, rate 1–5 on clarity) =. Transition =.</a:t>
+              <a:t>Activity: Visualization Fundamentals</a:t>
             </a:r>
           </a:p>
         </p:txBody>
@@ -3425,12 +3424,42 @@
           <a:lstStyle/>
           <a:p>
             <a:r>
-              <a:t>Duration: 12 min</a:t>
+              <a:t>Duration: 40 min</a:t>
             </a:r>
           </a:p>
           <a:p>
             <a:r>
               <a:t>Format: Whole Class</a:t>
+            </a:r>
+          </a:p>
+          <a:p>
+            <a:pPr lvl="1"/>
+            <a:r>
+              <a:t>Format: Hands-on + peer review</a:t>
+            </a:r>
+          </a:p>
+          <a:p>
+            <a:pPr lvl="1"/>
+            <a:r>
+              <a:t>Bloom’s: Apply + Evaluate Delivery: When…</a:t>
+            </a:r>
+          </a:p>
+          <a:p>
+            <a:pPr lvl="1"/>
+            <a:r>
+              <a:t>line vs</a:t>
+            </a:r>
+          </a:p>
+          <a:p>
+            <a:pPr lvl="1"/>
+            <a:r>
+              <a:t>scatter (rule: almost never use a…</a:t>
+            </a:r>
+          </a:p>
+          <a:p>
+            <a:pPr lvl="1"/>
+            <a:r>
+              <a:t>Design principles: label axes, no 3D,…</a:t>
             </a:r>
           </a:p>
         </p:txBody>
@@ -3564,7 +3593,7 @@
           <a:lstStyle/>
           <a:p>
             <a:r>
-              <a:t>Activity: Pacing: Upload + first prompt =. Compare AI vs. own findings =. Document discrepancies =. 2–3 students share a discrepancy =.</a:t>
+              <a:t>Activity: Day 1 Data Brief  |✆</a:t>
             </a:r>
           </a:p>
         </p:txBody>
@@ -3585,12 +3614,42 @@
           <a:lstStyle/>
           <a:p>
             <a:r>
-              <a:t>Duration: 5 min</a:t>
+              <a:t>Duration: 20 min</a:t>
             </a:r>
           </a:p>
           <a:p>
             <a:r>
               <a:t>Format: Whole Class</a:t>
+            </a:r>
+          </a:p>
+          <a:p>
+            <a:pPr lvl="1"/>
+            <a:r>
+              <a:t>Format: Individual writing + pair delivery</a:t>
+            </a:r>
+          </a:p>
+          <a:p>
+            <a:pPr lvl="1"/>
+            <a:r>
+              <a:t>Bloom’s: Create Delivery: 3-sentence summary of…</a:t>
+            </a:r>
+          </a:p>
+          <a:p>
+            <a:pPr lvl="1"/>
+            <a:r>
+              <a:t>This matters because [why]</a:t>
+            </a:r>
+          </a:p>
+          <a:p>
+            <a:pPr lvl="1"/>
+            <a:r>
+              <a:t>I recommend [what to do next]</a:t>
+            </a:r>
+          </a:p>
+          <a:p>
+            <a:pPr lvl="1"/>
+            <a:r>
+              <a:t>” Read aloud to partner</a:t>
             </a:r>
           </a:p>
         </p:txBody>
@@ -3629,7 +3688,7 @@
           <a:lstStyle/>
           <a:p>
             <a:r>
-              <a:t>Activity: Day 1 Data Brief  |✆</a:t>
+              <a:t>Activity: Day 1 Wrap</a:t>
             </a:r>
           </a:p>
         </p:txBody>
@@ -3650,42 +3709,12 @@
           <a:lstStyle/>
           <a:p>
             <a:r>
-              <a:t>Duration: 20 min</a:t>
+              <a:t>Duration: 30 min</a:t>
             </a:r>
           </a:p>
           <a:p>
             <a:r>
               <a:t>Format: Whole Class</a:t>
-            </a:r>
-          </a:p>
-          <a:p>
-            <a:pPr lvl="1"/>
-            <a:r>
-              <a:t>Format: Individual writing + pair delivery</a:t>
-            </a:r>
-          </a:p>
-          <a:p>
-            <a:pPr lvl="1"/>
-            <a:r>
-              <a:t>Bloom’s: Create Delivery: 3-sentence summary of…</a:t>
-            </a:r>
-          </a:p>
-          <a:p>
-            <a:pPr lvl="1"/>
-            <a:r>
-              <a:t>This matters because [why]</a:t>
-            </a:r>
-          </a:p>
-          <a:p>
-            <a:pPr lvl="1"/>
-            <a:r>
-              <a:t>I recommend [what to do next]</a:t>
-            </a:r>
-          </a:p>
-          <a:p>
-            <a:pPr lvl="1"/>
-            <a:r>
-              <a:t>” Read aloud to partner</a:t>
             </a:r>
           </a:p>
         </p:txBody>
@@ -3724,7 +3753,7 @@
           <a:lstStyle/>
           <a:p>
             <a:r>
-              <a:t>Activity: Pacing: Write 3-sentence brief =. Read aloud to partner + feedback =. Start Playbook (10 terms) =. Transition =.</a:t>
+              <a:t>Activity: Buffer / Overflow</a:t>
             </a:r>
           </a:p>
         </p:txBody>
@@ -3745,12 +3774,36 @@
           <a:lstStyle/>
           <a:p>
             <a:r>
-              <a:t>Duration: 7 min</a:t>
+              <a:t>Duration: 30 min</a:t>
             </a:r>
           </a:p>
           <a:p>
             <a:r>
               <a:t>Format: Whole Class</a:t>
+            </a:r>
+          </a:p>
+          <a:p>
+            <a:pPr lvl="1"/>
+            <a:r>
+              <a:t>Evidence the instructor looks for: Students…</a:t>
+            </a:r>
+          </a:p>
+          <a:p>
+            <a:pPr lvl="1"/>
+            <a:r>
+              <a:t>Chart peer reviews identify specific design…</a:t>
+            </a:r>
+          </a:p>
+          <a:p>
+            <a:pPr lvl="1"/>
+            <a:r>
+              <a:t>Data briefs lead with the finding,…</a:t>
+            </a:r>
+          </a:p>
+          <a:p>
+            <a:pPr lvl="1"/>
+            <a:r>
+              <a:t>AI comparison documents identify at least…</a:t>
             </a:r>
           </a:p>
         </p:txBody>
@@ -3789,7 +3842,7 @@
           <a:lstStyle/>
           <a:p>
             <a:r>
-              <a:t>Activity: Day 1 Wrap</a:t>
+              <a:t>Check for Understanding</a:t>
             </a:r>
           </a:p>
         </p:txBody>
@@ -3810,12 +3863,12 @@
           <a:lstStyle/>
           <a:p>
             <a:r>
-              <a:t>Duration: 30 min</a:t>
-            </a:r>
-          </a:p>
-          <a:p>
-            <a:r>
-              <a:t>Format: Whole Class</a:t>
+              <a:t>Technique: Think-Pair-Share</a:t>
+            </a:r>
+          </a:p>
+          <a:p>
+            <a:r>
+              <a:t>Can you demonstrate: Identify misleading charts and explain what makes a visualization trustworthy vs. deceptive (LO #1, #5)?</a:t>
             </a:r>
           </a:p>
         </p:txBody>
@@ -3854,7 +3907,7 @@
           <a:lstStyle/>
           <a:p>
             <a:r>
-              <a:t>Check for Understanding</a:t>
+              <a:t>Summary &amp; Closing</a:t>
             </a:r>
           </a:p>
         </p:txBody>
@@ -3875,12 +3928,19 @@
           <a:lstStyle/>
           <a:p>
             <a:r>
-              <a:t>Technique: Think-Pair-Share</a:t>
-            </a:r>
-          </a:p>
-          <a:p>
-            <a:r>
-              <a:t>Can you demonstrate: Session 1 Contribution?</a:t>
+              <a:t>Review key takeaways</a:t>
+            </a:r>
+          </a:p>
+          <a:p>
+            <a:pPr/>
+            <a:r>
+              <a:t>Complete exit ticket</a:t>
+            </a:r>
+          </a:p>
+          <a:p>
+            <a:pPr/>
+            <a:r>
+              <a:t>Preview next session</a:t>
             </a:r>
           </a:p>
         </p:txBody>
@@ -3940,109 +4000,37 @@
           <a:lstStyle/>
           <a:p>
             <a:r>
-              <a:t>SWBAT: Session 1 Contribution</a:t>
+              <a:t>SWBAT: Identify misleading charts and explain…</a:t>
             </a:r>
           </a:p>
           <a:p>
             <a:pPr/>
             <a:r>
-              <a:t>SWBAT: By the end of Session…</a:t>
+              <a:t>SWBAT: Use 4 spreadsheet functions (SORT,…</a:t>
             </a:r>
           </a:p>
           <a:p>
             <a:pPr/>
             <a:r>
-              <a:t>SWBAT: Identify misleading charts and explain…</a:t>
+              <a:t>SWBAT: Clean a messy dataset by…</a:t>
             </a:r>
           </a:p>
           <a:p>
             <a:pPr/>
             <a:r>
-              <a:t>SWBAT: Use 4 spreadsheet functions (SORT,…</a:t>
+              <a:t>SWBAT: Build 5 pivot tables answering…</a:t>
             </a:r>
           </a:p>
           <a:p>
             <a:pPr/>
             <a:r>
-              <a:t>SWBAT: Clean a messy dataset by…</a:t>
+              <a:t>SWBAT: Create 3 appropriate chart types…</a:t>
             </a:r>
           </a:p>
           <a:p>
             <a:pPr/>
             <a:r>
-              <a:t>SWBAT: Build 5 pivot tables answering…</a:t>
-            </a:r>
-          </a:p>
-        </p:txBody>
-      </p:sp>
-    </p:spTree>
-  </p:cSld>
-  <p:clrMapOvr>
-    <a:masterClrMapping/>
-  </p:clrMapOvr>
-</p:sld>
-</file>
-
-<file path=ppt/slides/slide20.xml><?xml version="1.0" encoding="utf-8"?>
-<p:sld xmlns:a="http://schemas.openxmlformats.org/drawingml/2006/main" xmlns:p="http://schemas.openxmlformats.org/presentationml/2006/main" xmlns:r="http://schemas.openxmlformats.org/officeDocument/2006/relationships">
-  <p:cSld>
-    <p:spTree>
-      <p:nvGrpSpPr>
-        <p:cNvPr id="1" name=""/>
-        <p:cNvGrpSpPr/>
-        <p:nvPr/>
-      </p:nvGrpSpPr>
-      <p:grpSpPr/>
-      <p:sp>
-        <p:nvSpPr>
-          <p:cNvPr id="2" name="Title 1"/>
-          <p:cNvSpPr>
-            <a:spLocks noGrp="1"/>
-          </p:cNvSpPr>
-          <p:nvPr>
-            <p:ph type="title"/>
-          </p:nvPr>
-        </p:nvSpPr>
-        <p:spPr/>
-        <p:txBody>
-          <a:bodyPr/>
-          <a:lstStyle/>
-          <a:p>
-            <a:r>
-              <a:t>Summary &amp; Closing</a:t>
-            </a:r>
-          </a:p>
-        </p:txBody>
-      </p:sp>
-      <p:sp>
-        <p:nvSpPr>
-          <p:cNvPr id="3" name="Content Placeholder 2"/>
-          <p:cNvSpPr>
-            <a:spLocks noGrp="1"/>
-          </p:cNvSpPr>
-          <p:nvPr>
-            <p:ph idx="1"/>
-          </p:nvPr>
-        </p:nvSpPr>
-        <p:spPr/>
-        <p:txBody>
-          <a:bodyPr/>
-          <a:lstStyle/>
-          <a:p>
-            <a:r>
-              <a:t>Review key takeaways</a:t>
-            </a:r>
-          </a:p>
-          <a:p>
-            <a:pPr/>
-            <a:r>
-              <a:t>Complete exit ticket</a:t>
-            </a:r>
-          </a:p>
-          <a:p>
-            <a:pPr/>
-            <a:r>
-              <a:t>Preview next session</a:t>
+              <a:t>SWBAT: Write a 3-sentence data brief…</a:t>
             </a:r>
           </a:p>
         </p:txBody>
@@ -4176,7 +4164,7 @@
           <a:lstStyle/>
           <a:p>
             <a:r>
-              <a:t>Activity: Pacing: Examples + discussion =. Poll + responses =. Reframe + bootcamp overview =. Logistics =.</a:t>
+              <a:t>Activity: “What’s Wrong with This Chart?”</a:t>
             </a:r>
           </a:p>
         </p:txBody>
@@ -4197,12 +4185,42 @@
           <a:lstStyle/>
           <a:p>
             <a:r>
-              <a:t>Duration: 8 min</a:t>
-            </a:r>
-          </a:p>
-          <a:p>
-            <a:r>
-              <a:t>Format: Discussion</a:t>
+              <a:t>Duration: 30 min</a:t>
+            </a:r>
+          </a:p>
+          <a:p>
+            <a:r>
+              <a:t>Format: Whole Class</a:t>
+            </a:r>
+          </a:p>
+          <a:p>
+            <a:pPr lvl="1"/>
+            <a:r>
+              <a:t>Format: Full group, interactive voting</a:t>
+            </a:r>
+          </a:p>
+          <a:p>
+            <a:pPr lvl="1"/>
+            <a:r>
+              <a:t>Bloom’s: Evaluate Delivery: 8 real-world visualizations—half…</a:t>
+            </a:r>
+          </a:p>
+          <a:p>
+            <a:pPr lvl="1"/>
+            <a:r>
+              <a:t>Students vote: trustworthy or misleading? Deconstruct…</a:t>
+            </a:r>
+          </a:p>
+          <a:p>
+            <a:pPr lvl="1"/>
+            <a:r>
+              <a:t>This teaches the critical eye before…</a:t>
+            </a:r>
+          </a:p>
+          <a:p>
+            <a:pPr lvl="1"/>
+            <a:r>
+              <a:t>Key message: the ability to spot…</a:t>
             </a:r>
           </a:p>
         </p:txBody>
@@ -4241,7 +4259,7 @@
           <a:lstStyle/>
           <a:p>
             <a:r>
-              <a:t>Activity: “What’s Wrong with This Chart?”</a:t>
+              <a:t>Activity: Data Literacy Framework + Five Questions</a:t>
             </a:r>
           </a:p>
         </p:txBody>
@@ -4262,7 +4280,7 @@
           <a:lstStyle/>
           <a:p>
             <a:r>
-              <a:t>Duration: 30 min</a:t>
+              <a:t>Duration: 25 min</a:t>
             </a:r>
           </a:p>
           <a:p>
@@ -4273,31 +4291,13 @@
           <a:p>
             <a:pPr lvl="1"/>
             <a:r>
-              <a:t>Format: Full group, interactive voting</a:t>
-            </a:r>
-          </a:p>
-          <a:p>
-            <a:pPr lvl="1"/>
-            <a:r>
-              <a:t>Bloom’s: Evaluate Delivery: 8 real-world visualizations—half…</a:t>
-            </a:r>
-          </a:p>
-          <a:p>
-            <a:pPr lvl="1"/>
-            <a:r>
-              <a:t>Students vote: trustworthy or misleading? Deconstruct…</a:t>
-            </a:r>
-          </a:p>
-          <a:p>
-            <a:pPr lvl="1"/>
-            <a:r>
-              <a:t>This teaches the critical eye before…</a:t>
-            </a:r>
-          </a:p>
-          <a:p>
-            <a:pPr lvl="1"/>
-            <a:r>
-              <a:t>Key message: the ability to spot…</a:t>
+              <a:t>Format: Interactive lecture + exercise</a:t>
+            </a:r>
+          </a:p>
+          <a:p>
+            <a:pPr lvl="1"/>
+            <a:r>
+              <a:t>Bloom’s: Understand</a:t>
             </a:r>
           </a:p>
         </p:txBody>
@@ -4336,7 +4336,7 @@
           <a:lstStyle/>
           <a:p>
             <a:r>
-              <a:t>Activity: Pacing: 8 charts ×each (show, vote, deconstruct) =. Setup + intro =. Wrap-up key principles =.</a:t>
+              <a:t>Activity: Break</a:t>
             </a:r>
           </a:p>
         </p:txBody>
@@ -4357,7 +4357,7 @@
           <a:lstStyle/>
           <a:p>
             <a:r>
-              <a:t>Duration: 3 min</a:t>
+              <a:t>Duration: 15 min</a:t>
             </a:r>
           </a:p>
           <a:p>
@@ -4401,7 +4401,7 @@
           <a:lstStyle/>
           <a:p>
             <a:r>
-              <a:t>Activity: Data Literacy Framework + Five Questions</a:t>
+              <a:t>Activity: Real Data, Real Questions</a:t>
             </a:r>
           </a:p>
         </p:txBody>
@@ -4422,7 +4422,7 @@
           <a:lstStyle/>
           <a:p>
             <a:r>
-              <a:t>Duration: 25 min</a:t>
+              <a:t>Duration: 35 min</a:t>
             </a:r>
           </a:p>
           <a:p>
@@ -4433,13 +4433,31 @@
           <a:p>
             <a:pPr lvl="1"/>
             <a:r>
-              <a:t>Format: Interactive lecture + exercise</a:t>
-            </a:r>
-          </a:p>
-          <a:p>
-            <a:pPr lvl="1"/>
-            <a:r>
-              <a:t>Bloom’s: Understand</a:t>
+              <a:t>Format: Small groups (4–5 students)</a:t>
+            </a:r>
+          </a:p>
+          <a:p>
+            <a:pPr lvl="1"/>
+            <a:r>
+              <a:t>Bloom’s: Analyze Delivery: Distribute 3 region-specific…</a:t>
+            </a:r>
+          </a:p>
+          <a:p>
+            <a:pPr lvl="1"/>
+            <a:r>
+              <a:t>Groups spend 20 minutes with raw…</a:t>
+            </a:r>
+          </a:p>
+          <a:p>
+            <a:pPr lvl="1"/>
+            <a:r>
+              <a:t>Don’t analyze yet—just look</a:t>
+            </a:r>
+          </a:p>
+          <a:p>
+            <a:pPr lvl="1"/>
+            <a:r>
+              <a:t>What do you notice? What questions…</a:t>
             </a:r>
           </a:p>
         </p:txBody>
@@ -4478,7 +4496,7 @@
           <a:lstStyle/>
           <a:p>
             <a:r>
-              <a:t>Activity: Data Cleaning — The Ugly Truth</a:t>
+              <a:t>Activity: Spreadsheet Power-Up (4 Functions)</a:t>
             </a:r>
           </a:p>
         </p:txBody>
@@ -4499,7 +4517,7 @@
           <a:lstStyle/>
           <a:p>
             <a:r>
-              <a:t>Duration: 30 min</a:t>
+              <a:t>Duration: 40 min</a:t>
             </a:r>
           </a:p>
           <a:p>
@@ -4510,31 +4528,25 @@
           <a:p>
             <a:pPr lvl="1"/>
             <a:r>
-              <a:t>Format: Hands-on, guided</a:t>
-            </a:r>
-          </a:p>
-          <a:p>
-            <a:pPr lvl="1"/>
-            <a:r>
-              <a:t>Bloom’s: Apply Delivery: Duplicates, blanks, inconsistent…</a:t>
-            </a:r>
-          </a:p>
-          <a:p>
-            <a:pPr lvl="1"/>
-            <a:r>
-              <a:t>Students clean a deliberately messy version…</a:t>
-            </a:r>
-          </a:p>
-          <a:p>
-            <a:pPr lvl="1"/>
-            <a:r>
-              <a:t>Teach each cleaning technique by encountering…</a:t>
-            </a:r>
-          </a:p>
-          <a:p>
-            <a:pPr lvl="1"/>
-            <a:r>
-              <a:t>” This is the work nobody…</a:t>
+              <a:t>Format: Hands-on, follow-along</a:t>
+            </a:r>
+          </a:p>
+          <a:p>
+            <a:pPr lvl="1"/>
+            <a:r>
+              <a:t>Bloom’s: Apply Delivery: SORT, FILTER, SUMIF/COUNTIF</a:t>
+            </a:r>
+          </a:p>
+          <a:p>
+            <a:pPr lvl="1"/>
+            <a:r>
+              <a:t>Each taught by answering a real…</a:t>
+            </a:r>
+          </a:p>
+          <a:p>
+            <a:pPr lvl="1"/>
+            <a:r>
+              <a:t>VLOOKUP is deliberately saved for Session…</a:t>
             </a:r>
           </a:p>
         </p:txBody>
@@ -4573,7 +4585,7 @@
           <a:lstStyle/>
           <a:p>
             <a:r>
-              <a:t>Activity: Pacing: Intro to common problems =. Guided cleaning walkthrough =. Students clean their own dataset =. Verification check =.</a:t>
+              <a:t>Activity: Lunch</a:t>
             </a:r>
           </a:p>
         </p:txBody>
@@ -4594,12 +4606,42 @@
           <a:lstStyle/>
           <a:p>
             <a:r>
-              <a:t>Duration: 5 min</a:t>
+              <a:t>Duration: 60 min</a:t>
             </a:r>
           </a:p>
           <a:p>
             <a:r>
               <a:t>Format: Whole Class</a:t>
+            </a:r>
+          </a:p>
+          <a:p>
+            <a:pPr lvl="1"/>
+            <a:r>
+              <a:t>Delivery: Data confidence self-assessment (1–5 across…</a:t>
+            </a:r>
+          </a:p>
+          <a:p>
+            <a:pPr lvl="1"/>
+            <a:r>
+              <a:t>This is the baseline</a:t>
+            </a:r>
+          </a:p>
+          <a:p>
+            <a:pPr lvl="1"/>
+            <a:r>
+              <a:t>Mid-week assignment preview: walk through the…</a:t>
+            </a:r>
+          </a:p>
+          <a:p>
+            <a:pPr lvl="1"/>
+            <a:r>
+              <a:t>Emphasize: you must use real professional…</a:t>
+            </a:r>
+          </a:p>
+          <a:p>
+            <a:pPr lvl="1"/>
+            <a:r>
+              <a:t>Show the documentation template</a:t>
             </a:r>
           </a:p>
         </p:txBody>

</xml_diff>